<commit_message>
Add JTAG debug mode guide for MicroBlaze RISC-V on Cmod A7-35T
</commit_message>
<xml_diff>
--- a/Intro_PPT/RISCV-MCU.pptx
+++ b/Intro_PPT/RISCV-MCU.pptx
@@ -6,7 +6,7 @@
     <p:sldMasterId id="2147483654" r:id="rId2"/>
   </p:sldMasterIdLst>
   <p:notesMasterIdLst>
-    <p:notesMasterId r:id="rId32"/>
+    <p:notesMasterId r:id="rId34"/>
   </p:notesMasterIdLst>
   <p:sldIdLst>
     <p:sldId id="256" r:id="rId3"/>
@@ -36,8 +36,10 @@
     <p:sldId id="280" r:id="rId27"/>
     <p:sldId id="281" r:id="rId28"/>
     <p:sldId id="300" r:id="rId29"/>
-    <p:sldId id="264" r:id="rId30"/>
-    <p:sldId id="287" r:id="rId31"/>
+    <p:sldId id="304" r:id="rId30"/>
+    <p:sldId id="303" r:id="rId31"/>
+    <p:sldId id="264" r:id="rId32"/>
+    <p:sldId id="287" r:id="rId33"/>
   </p:sldIdLst>
   <p:sldSz cx="12192000" cy="6858000"/>
   <p:notesSz cx="6858000" cy="9144000"/>
@@ -6189,7 +6191,7 @@
         <p:spPr>
           <a:xfrm>
             <a:off x="572575" y="1468582"/>
-            <a:ext cx="11213772" cy="3903954"/>
+            <a:ext cx="11213772" cy="4457952"/>
           </a:xfrm>
           <a:prstGeom prst="rect">
             <a:avLst/>
@@ -6213,7 +6215,7 @@
               <a:rPr lang="en-US" sz="2400" dirty="0">
                 <a:solidFill>
                   <a:schemeClr val="bg1">
-                    <a:lumMod val="75000"/>
+                    <a:lumMod val="65000"/>
                   </a:schemeClr>
                 </a:solidFill>
                 <a:latin typeface="Times New Roman" panose="02020603050405020304" pitchFamily="18" charset="0"/>
@@ -6234,7 +6236,7 @@
               <a:rPr lang="en-US" sz="2400" dirty="0">
                 <a:solidFill>
                   <a:schemeClr val="bg1">
-                    <a:lumMod val="75000"/>
+                    <a:lumMod val="65000"/>
                   </a:schemeClr>
                 </a:solidFill>
                 <a:latin typeface="Times New Roman" panose="02020603050405020304" pitchFamily="18" charset="0"/>
@@ -6293,10 +6295,6 @@
               </a:rPr>
               <a:t>Memory Hierarchy</a:t>
             </a:r>
-            <a:endParaRPr lang="en-US" altLang="zh-TW" sz="2400" dirty="0">
-              <a:latin typeface="Times New Roman" panose="02020603050405020304" pitchFamily="18" charset="0"/>
-              <a:cs typeface="Times New Roman" panose="02020603050405020304" pitchFamily="18" charset="0"/>
-            </a:endParaRPr>
           </a:p>
           <a:p>
             <a:pPr marL="285750" indent="-285750">
@@ -6310,7 +6308,7 @@
               <a:rPr lang="en-US" altLang="zh-TW" sz="2400" dirty="0">
                 <a:solidFill>
                   <a:schemeClr val="bg1">
-                    <a:lumMod val="75000"/>
+                    <a:lumMod val="65000"/>
                   </a:schemeClr>
                 </a:solidFill>
                 <a:latin typeface="Times New Roman" panose="02020603050405020304" pitchFamily="18" charset="0"/>
@@ -6321,7 +6319,7 @@
             <a:endParaRPr lang="en-US" sz="2400" dirty="0">
               <a:solidFill>
                 <a:schemeClr val="bg1">
-                  <a:lumMod val="75000"/>
+                  <a:lumMod val="65000"/>
                 </a:schemeClr>
               </a:solidFill>
               <a:latin typeface="Times New Roman" panose="02020603050405020304" pitchFamily="18" charset="0"/>
@@ -6340,7 +6338,7 @@
               <a:rPr lang="en-US" sz="2400" dirty="0">
                 <a:solidFill>
                   <a:schemeClr val="bg1">
-                    <a:lumMod val="75000"/>
+                    <a:lumMod val="65000"/>
                   </a:schemeClr>
                 </a:solidFill>
                 <a:latin typeface="Times New Roman" panose="02020603050405020304" pitchFamily="18" charset="0"/>
@@ -6361,7 +6359,28 @@
               <a:rPr lang="en-US" sz="2400" dirty="0">
                 <a:solidFill>
                   <a:schemeClr val="bg1">
-                    <a:lumMod val="75000"/>
+                    <a:lumMod val="65000"/>
+                  </a:schemeClr>
+                </a:solidFill>
+                <a:latin typeface="Times New Roman" panose="02020603050405020304" pitchFamily="18" charset="0"/>
+                <a:cs typeface="Times New Roman" panose="02020603050405020304" pitchFamily="18" charset="0"/>
+              </a:rPr>
+              <a:t>JTAG Debug Flow</a:t>
+            </a:r>
+          </a:p>
+          <a:p>
+            <a:pPr marL="285750" indent="-285750">
+              <a:lnSpc>
+                <a:spcPct val="150000"/>
+              </a:lnSpc>
+              <a:buFont typeface="Arial" panose="020B0604020202020204" pitchFamily="34" charset="0"/>
+              <a:buChar char="•"/>
+            </a:pPr>
+            <a:r>
+              <a:rPr lang="en-US" sz="2400" dirty="0">
+                <a:solidFill>
+                  <a:schemeClr val="bg1">
+                    <a:lumMod val="65000"/>
                   </a:schemeClr>
                 </a:solidFill>
                 <a:latin typeface="Times New Roman" panose="02020603050405020304" pitchFamily="18" charset="0"/>
@@ -12738,7 +12757,7 @@
         <p:spPr>
           <a:xfrm>
             <a:off x="572575" y="1468582"/>
-            <a:ext cx="11213772" cy="3903954"/>
+            <a:ext cx="11213772" cy="4457952"/>
           </a:xfrm>
           <a:prstGeom prst="rect">
             <a:avLst/>
@@ -12902,6 +12921,27 @@
                 <a:cs typeface="Times New Roman" panose="02020603050405020304" pitchFamily="18" charset="0"/>
               </a:rPr>
               <a:t>Software Design Flow</a:t>
+            </a:r>
+          </a:p>
+          <a:p>
+            <a:pPr marL="285750" indent="-285750">
+              <a:lnSpc>
+                <a:spcPct val="150000"/>
+              </a:lnSpc>
+              <a:buFont typeface="Arial" panose="020B0604020202020204" pitchFamily="34" charset="0"/>
+              <a:buChar char="•"/>
+            </a:pPr>
+            <a:r>
+              <a:rPr lang="en-US" sz="2400" dirty="0">
+                <a:solidFill>
+                  <a:schemeClr val="bg1">
+                    <a:lumMod val="65000"/>
+                  </a:schemeClr>
+                </a:solidFill>
+                <a:latin typeface="Times New Roman" panose="02020603050405020304" pitchFamily="18" charset="0"/>
+                <a:cs typeface="Times New Roman" panose="02020603050405020304" pitchFamily="18" charset="0"/>
+              </a:rPr>
+              <a:t>JTAG Debug Flow</a:t>
             </a:r>
           </a:p>
           <a:p>
@@ -13047,31 +13087,6 @@
               <a:t>19</a:t>
             </a:fld>
             <a:endParaRPr lang="en-TW"/>
-          </a:p>
-        </p:txBody>
-      </p:sp>
-      <p:sp>
-        <p:nvSpPr>
-          <p:cNvPr id="5" name="Content Placeholder 4">
-            <a:extLst>
-              <a:ext uri="{FF2B5EF4-FFF2-40B4-BE49-F238E27FC236}">
-                <a16:creationId xmlns:a16="http://schemas.microsoft.com/office/drawing/2014/main" id="{D001F177-0B4C-82EE-96C3-A9AFD3CE8E8A}"/>
-              </a:ext>
-            </a:extLst>
-          </p:cNvPr>
-          <p:cNvSpPr>
-            <a:spLocks noGrp="1"/>
-          </p:cNvSpPr>
-          <p:nvPr>
-            <p:ph/>
-          </p:nvPr>
-        </p:nvSpPr>
-        <p:spPr/>
-        <p:txBody>
-          <a:bodyPr/>
-          <a:lstStyle/>
-          <a:p>
-            <a:endParaRPr lang="en-TW" dirty="0"/>
           </a:p>
         </p:txBody>
       </p:sp>
@@ -13189,7 +13204,7 @@
         <p:spPr>
           <a:xfrm>
             <a:off x="572575" y="1468582"/>
-            <a:ext cx="11213772" cy="3903954"/>
+            <a:ext cx="11213772" cy="4457952"/>
           </a:xfrm>
           <a:prstGeom prst="rect">
             <a:avLst/>
@@ -13331,6 +13346,22 @@
                 <a:cs typeface="Times New Roman" panose="02020603050405020304" pitchFamily="18" charset="0"/>
               </a:rPr>
               <a:t>Software Design Flow</a:t>
+            </a:r>
+          </a:p>
+          <a:p>
+            <a:pPr marL="285750" indent="-285750">
+              <a:lnSpc>
+                <a:spcPct val="150000"/>
+              </a:lnSpc>
+              <a:buFont typeface="Arial" panose="020B0604020202020204" pitchFamily="34" charset="0"/>
+              <a:buChar char="•"/>
+            </a:pPr>
+            <a:r>
+              <a:rPr lang="en-US" sz="2400" dirty="0">
+                <a:latin typeface="Times New Roman" panose="02020603050405020304" pitchFamily="18" charset="0"/>
+                <a:cs typeface="Times New Roman" panose="02020603050405020304" pitchFamily="18" charset="0"/>
+              </a:rPr>
+              <a:t>JTAG Debug Flow</a:t>
             </a:r>
           </a:p>
           <a:p>
@@ -13434,7 +13465,7 @@
         <p:spPr>
           <a:xfrm>
             <a:off x="572575" y="1468582"/>
-            <a:ext cx="11213772" cy="3903954"/>
+            <a:ext cx="11213772" cy="4457952"/>
           </a:xfrm>
           <a:prstGeom prst="rect">
             <a:avLst/>
@@ -13593,6 +13624,27 @@
                 <a:cs typeface="Times New Roman" panose="02020603050405020304" pitchFamily="18" charset="0"/>
               </a:rPr>
               <a:t>Software Design Flow</a:t>
+            </a:r>
+          </a:p>
+          <a:p>
+            <a:pPr marL="285750" indent="-285750">
+              <a:lnSpc>
+                <a:spcPct val="150000"/>
+              </a:lnSpc>
+              <a:buFont typeface="Arial" panose="020B0604020202020204" pitchFamily="34" charset="0"/>
+              <a:buChar char="•"/>
+            </a:pPr>
+            <a:r>
+              <a:rPr lang="en-US" sz="2400" dirty="0">
+                <a:solidFill>
+                  <a:schemeClr val="bg1">
+                    <a:lumMod val="65000"/>
+                  </a:schemeClr>
+                </a:solidFill>
+                <a:latin typeface="Times New Roman" panose="02020603050405020304" pitchFamily="18" charset="0"/>
+                <a:cs typeface="Times New Roman" panose="02020603050405020304" pitchFamily="18" charset="0"/>
+              </a:rPr>
+              <a:t>JTAG Debug Flow</a:t>
             </a:r>
           </a:p>
           <a:p>
@@ -13954,7 +14006,7 @@
         <p:spPr>
           <a:xfrm>
             <a:off x="572575" y="1468582"/>
-            <a:ext cx="11213772" cy="3903954"/>
+            <a:ext cx="11213772" cy="4457952"/>
           </a:xfrm>
           <a:prstGeom prst="rect">
             <a:avLst/>
@@ -14118,6 +14170,27 @@
                 <a:cs typeface="Times New Roman" panose="02020603050405020304" pitchFamily="18" charset="0"/>
               </a:rPr>
               <a:t>Software Design Flow</a:t>
+            </a:r>
+          </a:p>
+          <a:p>
+            <a:pPr marL="285750" indent="-285750">
+              <a:lnSpc>
+                <a:spcPct val="150000"/>
+              </a:lnSpc>
+              <a:buFont typeface="Arial" panose="020B0604020202020204" pitchFamily="34" charset="0"/>
+              <a:buChar char="•"/>
+            </a:pPr>
+            <a:r>
+              <a:rPr lang="en-US" sz="2400" dirty="0">
+                <a:solidFill>
+                  <a:schemeClr val="bg1">
+                    <a:lumMod val="65000"/>
+                  </a:schemeClr>
+                </a:solidFill>
+                <a:latin typeface="Times New Roman" panose="02020603050405020304" pitchFamily="18" charset="0"/>
+                <a:cs typeface="Times New Roman" panose="02020603050405020304" pitchFamily="18" charset="0"/>
+              </a:rPr>
+              <a:t>JTAG Debug Flow</a:t>
             </a:r>
           </a:p>
           <a:p>
@@ -14638,26 +14711,6 @@
               </a:rPr>
               <a:t>Software Design Flow</a:t>
             </a:r>
-            <a:r>
-              <a:rPr lang="zh-TW" altLang="en-US" sz="4000" b="1" spc="-1" dirty="0">
-                <a:solidFill>
-                  <a:srgbClr val="DDDDDD"/>
-                </a:solidFill>
-                <a:latin typeface="Calibri"/>
-                <a:ea typeface="Calibri"/>
-              </a:rPr>
-              <a:t> </a:t>
-            </a:r>
-            <a:r>
-              <a:rPr lang="en-US" altLang="zh-TW" sz="4000" b="1" spc="-1" dirty="0">
-                <a:solidFill>
-                  <a:srgbClr val="DDDDDD"/>
-                </a:solidFill>
-                <a:latin typeface="Calibri"/>
-                <a:ea typeface="Calibri"/>
-              </a:rPr>
-              <a:t>for Debug</a:t>
-            </a:r>
             <a:endParaRPr lang="en-US" sz="4000" dirty="0"/>
           </a:p>
         </p:txBody>
@@ -15126,7 +15179,7 @@
                 <a:latin typeface="Calibri"/>
                 <a:ea typeface="Calibri"/>
               </a:rPr>
-              <a:t>Software Design Flow for Debug</a:t>
+              <a:t>Software Design Flow</a:t>
             </a:r>
             <a:endParaRPr lang="en-US" sz="4000" dirty="0"/>
           </a:p>
@@ -15412,7 +15465,7 @@
         <p:spPr>
           <a:xfrm>
             <a:off x="572575" y="1468582"/>
-            <a:ext cx="11213772" cy="3903954"/>
+            <a:ext cx="11213772" cy="4457952"/>
           </a:xfrm>
           <a:prstGeom prst="rect">
             <a:avLst/>
@@ -15593,6 +15646,27 @@
             </a:pPr>
             <a:r>
               <a:rPr lang="en-US" sz="2400" dirty="0">
+                <a:latin typeface="Times New Roman" panose="02020603050405020304" pitchFamily="18" charset="0"/>
+                <a:cs typeface="Times New Roman" panose="02020603050405020304" pitchFamily="18" charset="0"/>
+              </a:rPr>
+              <a:t>JTAG Debug Flow</a:t>
+            </a:r>
+          </a:p>
+          <a:p>
+            <a:pPr marL="285750" indent="-285750">
+              <a:lnSpc>
+                <a:spcPct val="150000"/>
+              </a:lnSpc>
+              <a:buFont typeface="Arial" panose="020B0604020202020204" pitchFamily="34" charset="0"/>
+              <a:buChar char="•"/>
+            </a:pPr>
+            <a:r>
+              <a:rPr lang="en-US" sz="2400" dirty="0">
+                <a:solidFill>
+                  <a:schemeClr val="bg1">
+                    <a:lumMod val="65000"/>
+                  </a:schemeClr>
+                </a:solidFill>
                 <a:latin typeface="Times New Roman" panose="02020603050405020304" pitchFamily="18" charset="0"/>
                 <a:cs typeface="Times New Roman" panose="02020603050405020304" pitchFamily="18" charset="0"/>
               </a:rPr>
@@ -15648,220 +15722,10 @@
   <p:cSld>
     <p:spTree>
       <p:nvGrpSpPr>
-        <p:cNvPr id="1" name=""/>
-        <p:cNvGrpSpPr/>
-        <p:nvPr/>
-      </p:nvGrpSpPr>
-      <p:grpSpPr>
-        <a:xfrm>
-          <a:off x="0" y="0"/>
-          <a:ext cx="0" cy="0"/>
-          <a:chOff x="0" y="0"/>
-          <a:chExt cx="0" cy="0"/>
-        </a:xfrm>
-      </p:grpSpPr>
-      <p:sp>
-        <p:nvSpPr>
-          <p:cNvPr id="129" name="PlaceHolder 1"/>
-          <p:cNvSpPr>
-            <a:spLocks noGrp="1"/>
-          </p:cNvSpPr>
-          <p:nvPr>
-            <p:ph type="title"/>
-          </p:nvPr>
-        </p:nvSpPr>
-        <p:spPr>
-          <a:xfrm>
-            <a:off x="1015920" y="0"/>
-            <a:ext cx="10972080" cy="1142280"/>
-          </a:xfrm>
-          <a:prstGeom prst="rect">
-            <a:avLst/>
-          </a:prstGeom>
-          <a:noFill/>
-          <a:ln w="0">
-            <a:noFill/>
-          </a:ln>
-        </p:spPr>
-        <p:txBody>
-          <a:bodyPr lIns="91440" tIns="45720" rIns="91440" bIns="45720" anchor="ctr">
-            <a:noAutofit/>
-          </a:bodyPr>
-          <a:lstStyle/>
-          <a:p>
-            <a:pPr indent="0">
-              <a:lnSpc>
-                <a:spcPct val="100000"/>
-              </a:lnSpc>
-              <a:buNone/>
-              <a:tabLst>
-                <a:tab pos="0" algn="l"/>
-              </a:tabLst>
-            </a:pPr>
-            <a:r>
-              <a:rPr lang="en-US" sz="4000" b="1" spc="-1" dirty="0">
-                <a:solidFill>
-                  <a:srgbClr val="DDDDDD"/>
-                </a:solidFill>
-                <a:latin typeface="Calibri"/>
-                <a:ea typeface="Calibri"/>
-              </a:rPr>
-              <a:t>Standalone Boot Sequence</a:t>
-            </a:r>
-            <a:endParaRPr lang="en-US" sz="4000" b="0" strike="noStrike" spc="-1" dirty="0">
-              <a:solidFill>
-                <a:srgbClr val="000000"/>
-              </a:solidFill>
-              <a:latin typeface="Arial"/>
-            </a:endParaRPr>
-          </a:p>
-        </p:txBody>
-      </p:sp>
-      <p:sp>
-        <p:nvSpPr>
-          <p:cNvPr id="131" name="AutoShape 3"/>
-          <p:cNvSpPr/>
-          <p:nvPr/>
-        </p:nvSpPr>
-        <p:spPr>
-          <a:xfrm>
-            <a:off x="5943600" y="3276720"/>
-            <a:ext cx="304200" cy="304200"/>
-          </a:xfrm>
-          <a:prstGeom prst="rect">
-            <a:avLst/>
-          </a:prstGeom>
-          <a:noFill/>
-          <a:ln w="0">
-            <a:noFill/>
-          </a:ln>
-        </p:spPr>
-        <p:style>
-          <a:lnRef idx="0">
-            <a:scrgbClr r="0" g="0" b="0"/>
-          </a:lnRef>
-          <a:fillRef idx="0">
-            <a:scrgbClr r="0" g="0" b="0"/>
-          </a:fillRef>
-          <a:effectRef idx="0">
-            <a:scrgbClr r="0" g="0" b="0"/>
-          </a:effectRef>
-          <a:fontRef idx="minor"/>
-        </p:style>
-        <p:txBody>
-          <a:bodyPr lIns="90000" tIns="45000" rIns="90000" bIns="45000" numCol="1" spcCol="0" anchor="t">
-            <a:noAutofit/>
-          </a:bodyPr>
-          <a:lstStyle/>
-          <a:p>
-            <a:pPr>
-              <a:lnSpc>
-                <a:spcPct val="100000"/>
-              </a:lnSpc>
-            </a:pPr>
-            <a:endParaRPr lang="en-US" sz="1400" b="0" strike="noStrike" spc="-1">
-              <a:solidFill>
-                <a:srgbClr val="000000"/>
-              </a:solidFill>
-              <a:latin typeface="Arial"/>
-              <a:ea typeface="Arial"/>
-            </a:endParaRPr>
-          </a:p>
-        </p:txBody>
-      </p:sp>
-      <p:sp>
-        <p:nvSpPr>
-          <p:cNvPr id="2" name="動作按鈕: 說明 1">
-            <a:hlinkClick r:id="" action="ppaction://noaction" highlightClick="1"/>
-            <a:extLst>
-              <a:ext uri="{FF2B5EF4-FFF2-40B4-BE49-F238E27FC236}">
-                <a16:creationId xmlns:a16="http://schemas.microsoft.com/office/drawing/2014/main" id="{003DCC72-29F7-D867-D27E-E276AEB886E7}"/>
-              </a:ext>
-            </a:extLst>
-          </p:cNvPr>
-          <p:cNvSpPr/>
-          <p:nvPr/>
-        </p:nvSpPr>
-        <p:spPr>
-          <a:xfrm>
-            <a:off x="2554664" y="2309567"/>
-            <a:ext cx="6985262" cy="3167406"/>
-          </a:xfrm>
-          <a:prstGeom prst="actionButtonHelp">
-            <a:avLst/>
-          </a:prstGeom>
-        </p:spPr>
-        <p:style>
-          <a:lnRef idx="2">
-            <a:schemeClr val="accent1">
-              <a:shade val="15000"/>
-            </a:schemeClr>
-          </a:lnRef>
-          <a:fillRef idx="1">
-            <a:schemeClr val="accent1"/>
-          </a:fillRef>
-          <a:effectRef idx="0">
-            <a:schemeClr val="accent1"/>
-          </a:effectRef>
-          <a:fontRef idx="minor">
-            <a:schemeClr val="lt1"/>
-          </a:fontRef>
-        </p:style>
-        <p:txBody>
-          <a:bodyPr rtlCol="0" anchor="ctr"/>
-          <a:lstStyle/>
-          <a:p>
-            <a:pPr algn="ctr"/>
-            <a:endParaRPr lang="en-US"/>
-          </a:p>
-        </p:txBody>
-      </p:sp>
-      <p:sp>
-        <p:nvSpPr>
-          <p:cNvPr id="3" name="Slide Number Placeholder 2">
-            <a:extLst>
-              <a:ext uri="{FF2B5EF4-FFF2-40B4-BE49-F238E27FC236}">
-                <a16:creationId xmlns:a16="http://schemas.microsoft.com/office/drawing/2014/main" id="{0228BB30-CB0B-8427-25AF-A0CA255B402F}"/>
-              </a:ext>
-            </a:extLst>
-          </p:cNvPr>
-          <p:cNvSpPr>
-            <a:spLocks noGrp="1"/>
-          </p:cNvSpPr>
-          <p:nvPr>
-            <p:ph type="sldNum" idx="10"/>
-          </p:nvPr>
-        </p:nvSpPr>
-        <p:spPr/>
-        <p:txBody>
-          <a:bodyPr/>
-          <a:lstStyle/>
-          <a:p>
-            <a:fld id="{5E7A655E-BA10-45EB-B439-1EA08694B58E}" type="slidenum">
-              <a:rPr lang="en-TW" smtClean="0"/>
-              <a:t>28</a:t>
-            </a:fld>
-            <a:endParaRPr lang="en-TW"/>
-          </a:p>
-        </p:txBody>
-      </p:sp>
-    </p:spTree>
-  </p:cSld>
-  <p:clrMapOvr>
-    <a:masterClrMapping/>
-  </p:clrMapOvr>
-</p:sld>
-</file>
-
-<file path=ppt/slides/slide29.xml><?xml version="1.0" encoding="utf-8"?>
-<p:sld xmlns:a="http://schemas.openxmlformats.org/drawingml/2006/main" xmlns:r="http://schemas.openxmlformats.org/officeDocument/2006/relationships" xmlns:p="http://schemas.openxmlformats.org/presentationml/2006/main">
-  <p:cSld>
-    <p:spTree>
-      <p:nvGrpSpPr>
         <p:cNvPr id="1" name="">
           <a:extLst>
             <a:ext uri="{FF2B5EF4-FFF2-40B4-BE49-F238E27FC236}">
-              <a16:creationId xmlns:a16="http://schemas.microsoft.com/office/drawing/2014/main" id="{EF09146F-4393-892E-2F12-74F505DADA0A}"/>
+              <a16:creationId xmlns:a16="http://schemas.microsoft.com/office/drawing/2014/main" id="{536355E2-8D8C-BE82-5BF8-D64A289BC6AA}"/>
             </a:ext>
           </a:extLst>
         </p:cNvPr>
@@ -15881,7 +15745,7 @@
           <p:cNvPr id="129" name="PlaceHolder 1">
             <a:extLst>
               <a:ext uri="{FF2B5EF4-FFF2-40B4-BE49-F238E27FC236}">
-                <a16:creationId xmlns:a16="http://schemas.microsoft.com/office/drawing/2014/main" id="{733187EC-F55F-314C-501F-ABB344AAF66F}"/>
+                <a16:creationId xmlns:a16="http://schemas.microsoft.com/office/drawing/2014/main" id="{6630D19B-1BA9-EF8E-9C47-E096B8258AC3}"/>
               </a:ext>
             </a:extLst>
           </p:cNvPr>
@@ -15921,14 +15785,13 @@
               </a:tabLst>
             </a:pPr>
             <a:r>
-              <a:rPr lang="en-US" altLang="zh-TW" sz="4000" b="1" strike="noStrike" spc="-1" dirty="0">
+              <a:rPr lang="en-US" sz="4000" b="1" spc="-1" dirty="0">
                 <a:solidFill>
                   <a:srgbClr val="DDDDDD"/>
                 </a:solidFill>
                 <a:latin typeface="Calibri"/>
-                <a:ea typeface="Calibri"/>
-              </a:rPr>
-              <a:t>Issue to Address</a:t>
+              </a:rPr>
+              <a:t>JTAG Debug Flow</a:t>
             </a:r>
             <a:endParaRPr lang="en-US" sz="4000" b="0" strike="noStrike" spc="-1" dirty="0">
               <a:solidFill>
@@ -15944,7 +15807,7 @@
           <p:cNvPr id="131" name="AutoShape 3">
             <a:extLst>
               <a:ext uri="{FF2B5EF4-FFF2-40B4-BE49-F238E27FC236}">
-                <a16:creationId xmlns:a16="http://schemas.microsoft.com/office/drawing/2014/main" id="{2CC01002-543C-89A6-5077-F58D57F7F171}"/>
+                <a16:creationId xmlns:a16="http://schemas.microsoft.com/office/drawing/2014/main" id="{5DC04991-490B-FA31-CF4D-3A390138A17A}"/>
               </a:ext>
             </a:extLst>
           </p:cNvPr>
@@ -15999,224 +15862,48 @@
       </p:sp>
       <p:sp>
         <p:nvSpPr>
-          <p:cNvPr id="2" name="文字方塊 1">
+          <p:cNvPr id="2" name="動作按鈕: 說明 1">
+            <a:hlinkClick r:id="" action="ppaction://noaction" highlightClick="1"/>
             <a:extLst>
               <a:ext uri="{FF2B5EF4-FFF2-40B4-BE49-F238E27FC236}">
-                <a16:creationId xmlns:a16="http://schemas.microsoft.com/office/drawing/2014/main" id="{00ADD298-6CC4-87F8-4C0B-13D75EAD4D37}"/>
+                <a16:creationId xmlns:a16="http://schemas.microsoft.com/office/drawing/2014/main" id="{43FCC448-A9B1-5427-37F1-D59C23D22D20}"/>
               </a:ext>
             </a:extLst>
           </p:cNvPr>
-          <p:cNvSpPr txBox="1"/>
+          <p:cNvSpPr/>
           <p:nvPr/>
         </p:nvSpPr>
         <p:spPr>
           <a:xfrm>
-            <a:off x="598394" y="1707776"/>
-            <a:ext cx="10972080" cy="3046988"/>
+            <a:off x="2554664" y="2309567"/>
+            <a:ext cx="6985262" cy="3167406"/>
           </a:xfrm>
-          <a:prstGeom prst="rect">
+          <a:prstGeom prst="actionButtonHelp">
             <a:avLst/>
           </a:prstGeom>
-          <a:noFill/>
         </p:spPr>
+        <p:style>
+          <a:lnRef idx="2">
+            <a:schemeClr val="accent1">
+              <a:shade val="15000"/>
+            </a:schemeClr>
+          </a:lnRef>
+          <a:fillRef idx="1">
+            <a:schemeClr val="accent1"/>
+          </a:fillRef>
+          <a:effectRef idx="0">
+            <a:schemeClr val="accent1"/>
+          </a:effectRef>
+          <a:fontRef idx="minor">
+            <a:schemeClr val="lt1"/>
+          </a:fontRef>
+        </p:style>
         <p:txBody>
-          <a:bodyPr wrap="square" rtlCol="0">
-            <a:spAutoFit/>
-          </a:bodyPr>
+          <a:bodyPr rtlCol="0" anchor="ctr"/>
           <a:lstStyle/>
           <a:p>
-            <a:pPr marL="285750" indent="-285750">
-              <a:buFont typeface="Arial" panose="020B0604020202020204" pitchFamily="34" charset="0"/>
-              <a:buChar char="•"/>
-            </a:pPr>
-            <a:r>
-              <a:rPr lang="en-US" sz="2400" dirty="0">
-                <a:latin typeface="Times New Roman" panose="02020603050405020304" pitchFamily="18" charset="0"/>
-                <a:cs typeface="Times New Roman" panose="02020603050405020304" pitchFamily="18" charset="0"/>
-              </a:rPr>
-              <a:t>Interrupt (GPIO / Timer)</a:t>
-            </a:r>
-          </a:p>
-          <a:p>
-            <a:pPr marL="285750" indent="-285750">
-              <a:buFont typeface="Arial" panose="020B0604020202020204" pitchFamily="34" charset="0"/>
-              <a:buChar char="•"/>
-            </a:pPr>
-            <a:r>
-              <a:rPr lang="en-US" sz="2400" dirty="0">
-                <a:latin typeface="Times New Roman" panose="02020603050405020304" pitchFamily="18" charset="0"/>
-                <a:cs typeface="Times New Roman" panose="02020603050405020304" pitchFamily="18" charset="0"/>
-              </a:rPr>
-              <a:t>GPIO input </a:t>
-            </a:r>
-          </a:p>
-          <a:p>
-            <a:pPr marL="285750" indent="-285750">
-              <a:buFont typeface="Arial" panose="020B0604020202020204" pitchFamily="34" charset="0"/>
-              <a:buChar char="•"/>
-            </a:pPr>
-            <a:r>
-              <a:rPr lang="en-US" sz="2400" dirty="0" err="1">
-                <a:latin typeface="Times New Roman" panose="02020603050405020304" pitchFamily="18" charset="0"/>
-                <a:cs typeface="Times New Roman" panose="02020603050405020304" pitchFamily="18" charset="0"/>
-              </a:rPr>
-              <a:t>uart</a:t>
-            </a:r>
-            <a:r>
-              <a:rPr lang="en-US" sz="2400" dirty="0">
-                <a:latin typeface="Times New Roman" panose="02020603050405020304" pitchFamily="18" charset="0"/>
-                <a:cs typeface="Times New Roman" panose="02020603050405020304" pitchFamily="18" charset="0"/>
-              </a:rPr>
-              <a:t> 16550 Baud Rate </a:t>
-            </a:r>
-            <a:r>
-              <a:rPr lang="zh-TW" altLang="en-US" sz="2400" dirty="0">
-                <a:latin typeface="Times New Roman" panose="02020603050405020304" pitchFamily="18" charset="0"/>
-                <a:cs typeface="Times New Roman" panose="02020603050405020304" pitchFamily="18" charset="0"/>
-              </a:rPr>
-              <a:t>更改 </a:t>
-            </a:r>
-            <a:endParaRPr lang="en-US" altLang="zh-TW" sz="2400" dirty="0">
-              <a:latin typeface="Times New Roman" panose="02020603050405020304" pitchFamily="18" charset="0"/>
-              <a:cs typeface="Times New Roman" panose="02020603050405020304" pitchFamily="18" charset="0"/>
-            </a:endParaRPr>
-          </a:p>
-          <a:p>
-            <a:pPr marL="285750" indent="-285750">
-              <a:buFont typeface="Arial" panose="020B0604020202020204" pitchFamily="34" charset="0"/>
-              <a:buChar char="•"/>
-            </a:pPr>
-            <a:r>
-              <a:rPr lang="en-US" sz="2400" dirty="0">
-                <a:latin typeface="Times New Roman" panose="02020603050405020304" pitchFamily="18" charset="0"/>
-                <a:cs typeface="Times New Roman" panose="02020603050405020304" pitchFamily="18" charset="0"/>
-              </a:rPr>
-              <a:t>XADC </a:t>
-            </a:r>
-            <a:r>
-              <a:rPr lang="zh-TW" altLang="en-US" sz="2400" dirty="0">
-                <a:latin typeface="Times New Roman" panose="02020603050405020304" pitchFamily="18" charset="0"/>
-                <a:cs typeface="Times New Roman" panose="02020603050405020304" pitchFamily="18" charset="0"/>
-              </a:rPr>
-              <a:t>五個</a:t>
-            </a:r>
-            <a:r>
-              <a:rPr lang="en-US" altLang="zh-TW" sz="2400" dirty="0">
-                <a:latin typeface="Times New Roman" panose="02020603050405020304" pitchFamily="18" charset="0"/>
-                <a:cs typeface="Times New Roman" panose="02020603050405020304" pitchFamily="18" charset="0"/>
-              </a:rPr>
-              <a:t>channel</a:t>
-            </a:r>
-            <a:r>
-              <a:rPr lang="zh-TW" altLang="en-US" sz="2400" dirty="0">
-                <a:latin typeface="Times New Roman" panose="02020603050405020304" pitchFamily="18" charset="0"/>
-                <a:cs typeface="Times New Roman" panose="02020603050405020304" pitchFamily="18" charset="0"/>
-              </a:rPr>
-              <a:t>讀值</a:t>
-            </a:r>
-            <a:endParaRPr lang="en-US" sz="2400" dirty="0">
-              <a:latin typeface="Times New Roman" panose="02020603050405020304" pitchFamily="18" charset="0"/>
-              <a:cs typeface="Times New Roman" panose="02020603050405020304" pitchFamily="18" charset="0"/>
-            </a:endParaRPr>
-          </a:p>
-          <a:p>
-            <a:pPr marL="285750" indent="-285750">
-              <a:buFont typeface="Arial" panose="020B0604020202020204" pitchFamily="34" charset="0"/>
-              <a:buChar char="•"/>
-            </a:pPr>
-            <a:r>
-              <a:rPr lang="en-US" sz="2400" dirty="0">
-                <a:latin typeface="Times New Roman" panose="02020603050405020304" pitchFamily="18" charset="0"/>
-                <a:cs typeface="Times New Roman" panose="02020603050405020304" pitchFamily="18" charset="0"/>
-              </a:rPr>
-              <a:t>QSPI </a:t>
-            </a:r>
-            <a:r>
-              <a:rPr lang="zh-TW" altLang="en-US" sz="2400" dirty="0">
-                <a:latin typeface="Times New Roman" panose="02020603050405020304" pitchFamily="18" charset="0"/>
-                <a:cs typeface="Times New Roman" panose="02020603050405020304" pitchFamily="18" charset="0"/>
-              </a:rPr>
-              <a:t>內建 </a:t>
-            </a:r>
-            <a:r>
-              <a:rPr lang="en-US" sz="2400" dirty="0">
-                <a:latin typeface="Times New Roman" panose="02020603050405020304" pitchFamily="18" charset="0"/>
-                <a:cs typeface="Times New Roman" panose="02020603050405020304" pitchFamily="18" charset="0"/>
-              </a:rPr>
-              <a:t>Bitstream </a:t>
-            </a:r>
-          </a:p>
-          <a:p>
-            <a:pPr marL="285750" indent="-285750">
-              <a:buFont typeface="Arial" panose="020B0604020202020204" pitchFamily="34" charset="0"/>
-              <a:buChar char="•"/>
-            </a:pPr>
-            <a:r>
-              <a:rPr lang="en-US" sz="2400" dirty="0">
-                <a:latin typeface="Times New Roman" panose="02020603050405020304" pitchFamily="18" charset="0"/>
-                <a:cs typeface="Times New Roman" panose="02020603050405020304" pitchFamily="18" charset="0"/>
-              </a:rPr>
-              <a:t>EMC SRAM </a:t>
-            </a:r>
-            <a:r>
-              <a:rPr lang="zh-TW" altLang="en-US" sz="2400" dirty="0">
-                <a:latin typeface="Times New Roman" panose="02020603050405020304" pitchFamily="18" charset="0"/>
-                <a:cs typeface="Times New Roman" panose="02020603050405020304" pitchFamily="18" charset="0"/>
-              </a:rPr>
-              <a:t>使用</a:t>
-            </a:r>
-            <a:endParaRPr lang="en-US" altLang="zh-TW" sz="2400" dirty="0">
-              <a:latin typeface="Times New Roman" panose="02020603050405020304" pitchFamily="18" charset="0"/>
-              <a:cs typeface="Times New Roman" panose="02020603050405020304" pitchFamily="18" charset="0"/>
-            </a:endParaRPr>
-          </a:p>
-          <a:p>
-            <a:pPr marL="285750" indent="-285750">
-              <a:buFont typeface="Arial" panose="020B0604020202020204" pitchFamily="34" charset="0"/>
-              <a:buChar char="•"/>
-            </a:pPr>
-            <a:r>
-              <a:rPr lang="en-US" sz="2400" dirty="0">
-                <a:latin typeface="Times New Roman" panose="02020603050405020304" pitchFamily="18" charset="0"/>
-                <a:cs typeface="Times New Roman" panose="02020603050405020304" pitchFamily="18" charset="0"/>
-              </a:rPr>
-              <a:t>Memory Hier</a:t>
-            </a:r>
-            <a:r>
-              <a:rPr lang="zh-TW" altLang="en-US" sz="2400" dirty="0">
-                <a:latin typeface="Times New Roman" panose="02020603050405020304" pitchFamily="18" charset="0"/>
-                <a:cs typeface="Times New Roman" panose="02020603050405020304" pitchFamily="18" charset="0"/>
-              </a:rPr>
-              <a:t> 設計</a:t>
-            </a:r>
-            <a:endParaRPr lang="en-US" altLang="zh-TW" sz="2400" dirty="0">
-              <a:latin typeface="Times New Roman" panose="02020603050405020304" pitchFamily="18" charset="0"/>
-              <a:cs typeface="Times New Roman" panose="02020603050405020304" pitchFamily="18" charset="0"/>
-            </a:endParaRPr>
-          </a:p>
-          <a:p>
-            <a:pPr marL="285750" indent="-285750">
-              <a:buFont typeface="Arial" panose="020B0604020202020204" pitchFamily="34" charset="0"/>
-              <a:buChar char="•"/>
-            </a:pPr>
-            <a:r>
-              <a:rPr lang="en-US" altLang="zh-TW" sz="2400" dirty="0">
-                <a:latin typeface="Times New Roman" panose="02020603050405020304" pitchFamily="18" charset="0"/>
-                <a:cs typeface="Times New Roman" panose="02020603050405020304" pitchFamily="18" charset="0"/>
-              </a:rPr>
-              <a:t>Standalone Boot Sequence</a:t>
-            </a:r>
-            <a:r>
-              <a:rPr lang="zh-TW" altLang="en-US" sz="2400" dirty="0">
-                <a:latin typeface="Times New Roman" panose="02020603050405020304" pitchFamily="18" charset="0"/>
-                <a:cs typeface="Times New Roman" panose="02020603050405020304" pitchFamily="18" charset="0"/>
-              </a:rPr>
-              <a:t>流程</a:t>
-            </a:r>
-            <a:endParaRPr lang="en-US" sz="2400" dirty="0">
-              <a:latin typeface="Times New Roman" panose="02020603050405020304" pitchFamily="18" charset="0"/>
-              <a:cs typeface="Times New Roman" panose="02020603050405020304" pitchFamily="18" charset="0"/>
-            </a:endParaRPr>
+            <a:pPr algn="ctr"/>
+            <a:endParaRPr lang="en-US"/>
           </a:p>
         </p:txBody>
       </p:sp>
@@ -16225,7 +15912,7 @@
           <p:cNvPr id="3" name="Slide Number Placeholder 2">
             <a:extLst>
               <a:ext uri="{FF2B5EF4-FFF2-40B4-BE49-F238E27FC236}">
-                <a16:creationId xmlns:a16="http://schemas.microsoft.com/office/drawing/2014/main" id="{8EC85FAF-B12B-E4FB-0C54-D03C84646C5C}"/>
+                <a16:creationId xmlns:a16="http://schemas.microsoft.com/office/drawing/2014/main" id="{A46BADAD-3AC3-ED5E-3EAD-EF0F2DCFF1B0}"/>
               </a:ext>
             </a:extLst>
           </p:cNvPr>
@@ -16243,7 +15930,7 @@
           <a:p>
             <a:fld id="{5E7A655E-BA10-45EB-B439-1EA08694B58E}" type="slidenum">
               <a:rPr lang="en-TW" smtClean="0"/>
-              <a:t>29</a:t>
+              <a:t>28</a:t>
             </a:fld>
             <a:endParaRPr lang="en-TW"/>
           </a:p>
@@ -16252,7 +15939,297 @@
     </p:spTree>
     <p:extLst>
       <p:ext uri="{BB962C8B-B14F-4D97-AF65-F5344CB8AC3E}">
-        <p14:creationId xmlns:p14="http://schemas.microsoft.com/office/powerpoint/2010/main" val="1021360517"/>
+        <p14:creationId xmlns:p14="http://schemas.microsoft.com/office/powerpoint/2010/main" val="2042655001"/>
+      </p:ext>
+    </p:extLst>
+  </p:cSld>
+  <p:clrMapOvr>
+    <a:masterClrMapping/>
+  </p:clrMapOvr>
+</p:sld>
+</file>
+
+<file path=ppt/slides/slide29.xml><?xml version="1.0" encoding="utf-8"?>
+<p:sld xmlns:a="http://schemas.openxmlformats.org/drawingml/2006/main" xmlns:r="http://schemas.openxmlformats.org/officeDocument/2006/relationships" xmlns:p="http://schemas.openxmlformats.org/presentationml/2006/main">
+  <p:cSld>
+    <p:spTree>
+      <p:nvGrpSpPr>
+        <p:cNvPr id="1" name="">
+          <a:extLst>
+            <a:ext uri="{FF2B5EF4-FFF2-40B4-BE49-F238E27FC236}">
+              <a16:creationId xmlns:a16="http://schemas.microsoft.com/office/drawing/2014/main" id="{DBD334A9-887E-0379-E9A8-0B87329B9692}"/>
+            </a:ext>
+          </a:extLst>
+        </p:cNvPr>
+        <p:cNvGrpSpPr/>
+        <p:nvPr/>
+      </p:nvGrpSpPr>
+      <p:grpSpPr>
+        <a:xfrm>
+          <a:off x="0" y="0"/>
+          <a:ext cx="0" cy="0"/>
+          <a:chOff x="0" y="0"/>
+          <a:chExt cx="0" cy="0"/>
+        </a:xfrm>
+      </p:grpSpPr>
+      <p:sp>
+        <p:nvSpPr>
+          <p:cNvPr id="4" name="文字方塊 3">
+            <a:extLst>
+              <a:ext uri="{FF2B5EF4-FFF2-40B4-BE49-F238E27FC236}">
+                <a16:creationId xmlns:a16="http://schemas.microsoft.com/office/drawing/2014/main" id="{B6FE46E2-6884-8E38-0EE2-E3D2FDFAB16C}"/>
+              </a:ext>
+            </a:extLst>
+          </p:cNvPr>
+          <p:cNvSpPr txBox="1"/>
+          <p:nvPr/>
+        </p:nvSpPr>
+        <p:spPr>
+          <a:xfrm>
+            <a:off x="572575" y="1468582"/>
+            <a:ext cx="11213772" cy="4457952"/>
+          </a:xfrm>
+          <a:prstGeom prst="rect">
+            <a:avLst/>
+          </a:prstGeom>
+          <a:noFill/>
+        </p:spPr>
+        <p:txBody>
+          <a:bodyPr wrap="square" rtlCol="0">
+            <a:spAutoFit/>
+          </a:bodyPr>
+          <a:lstStyle/>
+          <a:p>
+            <a:pPr marL="285750" indent="-285750">
+              <a:lnSpc>
+                <a:spcPct val="150000"/>
+              </a:lnSpc>
+              <a:buFont typeface="Arial" panose="020B0604020202020204" pitchFamily="34" charset="0"/>
+              <a:buChar char="•"/>
+            </a:pPr>
+            <a:r>
+              <a:rPr lang="en-US" sz="2400" dirty="0">
+                <a:solidFill>
+                  <a:schemeClr val="bg1">
+                    <a:lumMod val="65000"/>
+                  </a:schemeClr>
+                </a:solidFill>
+                <a:latin typeface="Times New Roman" panose="02020603050405020304" pitchFamily="18" charset="0"/>
+                <a:cs typeface="Times New Roman" panose="02020603050405020304" pitchFamily="18" charset="0"/>
+              </a:rPr>
+              <a:t>FPGA Selection and Spec</a:t>
+            </a:r>
+          </a:p>
+          <a:p>
+            <a:pPr marL="285750" indent="-285750">
+              <a:lnSpc>
+                <a:spcPct val="150000"/>
+              </a:lnSpc>
+              <a:buFont typeface="Arial" panose="020B0604020202020204" pitchFamily="34" charset="0"/>
+              <a:buChar char="•"/>
+            </a:pPr>
+            <a:r>
+              <a:rPr lang="en-US" sz="2400" dirty="0">
+                <a:solidFill>
+                  <a:schemeClr val="bg1">
+                    <a:lumMod val="65000"/>
+                  </a:schemeClr>
+                </a:solidFill>
+                <a:latin typeface="Times New Roman" panose="02020603050405020304" pitchFamily="18" charset="0"/>
+                <a:cs typeface="Times New Roman" panose="02020603050405020304" pitchFamily="18" charset="0"/>
+              </a:rPr>
+              <a:t>Overview Microcontroller / AXI Mapping</a:t>
+            </a:r>
+          </a:p>
+          <a:p>
+            <a:pPr marL="285750" indent="-285750">
+              <a:lnSpc>
+                <a:spcPct val="150000"/>
+              </a:lnSpc>
+              <a:buFont typeface="Arial" panose="020B0604020202020204" pitchFamily="34" charset="0"/>
+              <a:buChar char="•"/>
+            </a:pPr>
+            <a:r>
+              <a:rPr lang="en-US" sz="2400" dirty="0">
+                <a:solidFill>
+                  <a:schemeClr val="bg1">
+                    <a:lumMod val="65000"/>
+                  </a:schemeClr>
+                </a:solidFill>
+                <a:latin typeface="Times New Roman" panose="02020603050405020304" pitchFamily="18" charset="0"/>
+                <a:cs typeface="Times New Roman" panose="02020603050405020304" pitchFamily="18" charset="0"/>
+              </a:rPr>
+              <a:t>GPIO / Interrupt System / </a:t>
+            </a:r>
+            <a:r>
+              <a:rPr lang="zh-TW" altLang="en-US" sz="2400" dirty="0">
+                <a:solidFill>
+                  <a:schemeClr val="bg1">
+                    <a:lumMod val="65000"/>
+                  </a:schemeClr>
+                </a:solidFill>
+                <a:latin typeface="Times New Roman" panose="02020603050405020304" pitchFamily="18" charset="0"/>
+                <a:cs typeface="Times New Roman" panose="02020603050405020304" pitchFamily="18" charset="0"/>
+              </a:rPr>
+              <a:t> </a:t>
+            </a:r>
+            <a:r>
+              <a:rPr lang="en-US" altLang="zh-TW" sz="2400" dirty="0">
+                <a:solidFill>
+                  <a:schemeClr val="bg1">
+                    <a:lumMod val="65000"/>
+                  </a:schemeClr>
+                </a:solidFill>
+                <a:latin typeface="Times New Roman" panose="02020603050405020304" pitchFamily="18" charset="0"/>
+                <a:cs typeface="Times New Roman" panose="02020603050405020304" pitchFamily="18" charset="0"/>
+              </a:rPr>
+              <a:t>Timer &amp; PWM / XADC / UART</a:t>
+            </a:r>
+          </a:p>
+          <a:p>
+            <a:pPr marL="285750" indent="-285750">
+              <a:lnSpc>
+                <a:spcPct val="150000"/>
+              </a:lnSpc>
+              <a:buFont typeface="Arial" panose="020B0604020202020204" pitchFamily="34" charset="0"/>
+              <a:buChar char="•"/>
+            </a:pPr>
+            <a:r>
+              <a:rPr lang="en-US" altLang="zh-TW" sz="2400" dirty="0">
+                <a:solidFill>
+                  <a:schemeClr val="bg1">
+                    <a:lumMod val="65000"/>
+                  </a:schemeClr>
+                </a:solidFill>
+                <a:latin typeface="Times New Roman" panose="02020603050405020304" pitchFamily="18" charset="0"/>
+                <a:cs typeface="Times New Roman" panose="02020603050405020304" pitchFamily="18" charset="0"/>
+              </a:rPr>
+              <a:t>Memory Hierarchy</a:t>
+            </a:r>
+          </a:p>
+          <a:p>
+            <a:pPr marL="285750" indent="-285750">
+              <a:lnSpc>
+                <a:spcPct val="150000"/>
+              </a:lnSpc>
+              <a:buFont typeface="Arial" panose="020B0604020202020204" pitchFamily="34" charset="0"/>
+              <a:buChar char="•"/>
+            </a:pPr>
+            <a:r>
+              <a:rPr lang="en-US" altLang="zh-TW" sz="2400" dirty="0">
+                <a:solidFill>
+                  <a:schemeClr val="bg1">
+                    <a:lumMod val="65000"/>
+                  </a:schemeClr>
+                </a:solidFill>
+                <a:latin typeface="Times New Roman" panose="02020603050405020304" pitchFamily="18" charset="0"/>
+                <a:cs typeface="Times New Roman" panose="02020603050405020304" pitchFamily="18" charset="0"/>
+              </a:rPr>
+              <a:t>Hardware Report</a:t>
+            </a:r>
+            <a:endParaRPr lang="en-US" sz="2400" dirty="0">
+              <a:solidFill>
+                <a:schemeClr val="bg1">
+                  <a:lumMod val="65000"/>
+                </a:schemeClr>
+              </a:solidFill>
+              <a:latin typeface="Times New Roman" panose="02020603050405020304" pitchFamily="18" charset="0"/>
+              <a:cs typeface="Times New Roman" panose="02020603050405020304" pitchFamily="18" charset="0"/>
+            </a:endParaRPr>
+          </a:p>
+          <a:p>
+            <a:pPr marL="285750" indent="-285750">
+              <a:lnSpc>
+                <a:spcPct val="150000"/>
+              </a:lnSpc>
+              <a:buFont typeface="Arial" panose="020B0604020202020204" pitchFamily="34" charset="0"/>
+              <a:buChar char="•"/>
+            </a:pPr>
+            <a:r>
+              <a:rPr lang="en-US" sz="2400" dirty="0">
+                <a:solidFill>
+                  <a:schemeClr val="bg1">
+                    <a:lumMod val="65000"/>
+                  </a:schemeClr>
+                </a:solidFill>
+                <a:latin typeface="Times New Roman" panose="02020603050405020304" pitchFamily="18" charset="0"/>
+                <a:cs typeface="Times New Roman" panose="02020603050405020304" pitchFamily="18" charset="0"/>
+              </a:rPr>
+              <a:t>Software Design Flow</a:t>
+            </a:r>
+          </a:p>
+          <a:p>
+            <a:pPr marL="285750" indent="-285750">
+              <a:lnSpc>
+                <a:spcPct val="150000"/>
+              </a:lnSpc>
+              <a:buFont typeface="Arial" panose="020B0604020202020204" pitchFamily="34" charset="0"/>
+              <a:buChar char="•"/>
+            </a:pPr>
+            <a:r>
+              <a:rPr lang="en-US" sz="2400" dirty="0">
+                <a:solidFill>
+                  <a:schemeClr val="bg1">
+                    <a:lumMod val="65000"/>
+                  </a:schemeClr>
+                </a:solidFill>
+                <a:latin typeface="Times New Roman" panose="02020603050405020304" pitchFamily="18" charset="0"/>
+                <a:cs typeface="Times New Roman" panose="02020603050405020304" pitchFamily="18" charset="0"/>
+              </a:rPr>
+              <a:t>JTAG Debug Flow</a:t>
+            </a:r>
+          </a:p>
+          <a:p>
+            <a:pPr marL="285750" indent="-285750">
+              <a:lnSpc>
+                <a:spcPct val="150000"/>
+              </a:lnSpc>
+              <a:buFont typeface="Arial" panose="020B0604020202020204" pitchFamily="34" charset="0"/>
+              <a:buChar char="•"/>
+            </a:pPr>
+            <a:r>
+              <a:rPr lang="en-US" sz="2400" dirty="0">
+                <a:latin typeface="Times New Roman" panose="02020603050405020304" pitchFamily="18" charset="0"/>
+                <a:cs typeface="Times New Roman" panose="02020603050405020304" pitchFamily="18" charset="0"/>
+              </a:rPr>
+              <a:t>Standalone Boot Sequence</a:t>
+            </a:r>
+          </a:p>
+        </p:txBody>
+      </p:sp>
+      <p:sp>
+        <p:nvSpPr>
+          <p:cNvPr id="2" name="Slide Number Placeholder 1">
+            <a:extLst>
+              <a:ext uri="{FF2B5EF4-FFF2-40B4-BE49-F238E27FC236}">
+                <a16:creationId xmlns:a16="http://schemas.microsoft.com/office/drawing/2014/main" id="{775A9C5E-439C-66E9-1069-2FD157FC2825}"/>
+              </a:ext>
+            </a:extLst>
+          </p:cNvPr>
+          <p:cNvSpPr>
+            <a:spLocks noGrp="1"/>
+          </p:cNvSpPr>
+          <p:nvPr>
+            <p:ph type="sldNum" idx="10"/>
+          </p:nvPr>
+        </p:nvSpPr>
+        <p:spPr/>
+        <p:txBody>
+          <a:bodyPr/>
+          <a:lstStyle/>
+          <a:p>
+            <a:fld id="{5E7A655E-BA10-45EB-B439-1EA08694B58E}" type="slidenum">
+              <a:rPr lang="en-TW" smtClean="0"/>
+              <a:t>29</a:t>
+            </a:fld>
+            <a:endParaRPr lang="en-TW"/>
+          </a:p>
+        </p:txBody>
+      </p:sp>
+    </p:spTree>
+    <p:extLst>
+      <p:ext uri="{BB962C8B-B14F-4D97-AF65-F5344CB8AC3E}">
+        <p14:creationId xmlns:p14="http://schemas.microsoft.com/office/powerpoint/2010/main" val="4023069193"/>
       </p:ext>
     </p:extLst>
   </p:cSld>
@@ -16363,7 +16340,7 @@
         <p:spPr>
           <a:xfrm>
             <a:off x="572575" y="1468582"/>
-            <a:ext cx="11213772" cy="3903954"/>
+            <a:ext cx="11213772" cy="4457952"/>
           </a:xfrm>
           <a:prstGeom prst="rect">
             <a:avLst/>
@@ -16526,10 +16503,19 @@
                 <a:latin typeface="Times New Roman" panose="02020603050405020304" pitchFamily="18" charset="0"/>
                 <a:cs typeface="Times New Roman" panose="02020603050405020304" pitchFamily="18" charset="0"/>
               </a:rPr>
-              <a:t>Software </a:t>
-            </a:r>
-            <a:r>
-              <a:rPr lang="en-US" sz="2400">
+              <a:t>Software Design Flow</a:t>
+            </a:r>
+          </a:p>
+          <a:p>
+            <a:pPr marL="285750" indent="-285750">
+              <a:lnSpc>
+                <a:spcPct val="150000"/>
+              </a:lnSpc>
+              <a:buFont typeface="Arial" panose="020B0604020202020204" pitchFamily="34" charset="0"/>
+              <a:buChar char="•"/>
+            </a:pPr>
+            <a:r>
+              <a:rPr lang="en-US" sz="2400" dirty="0">
                 <a:solidFill>
                   <a:schemeClr val="bg1">
                     <a:lumMod val="65000"/>
@@ -16538,17 +16524,8 @@
                 <a:latin typeface="Times New Roman" panose="02020603050405020304" pitchFamily="18" charset="0"/>
                 <a:cs typeface="Times New Roman" panose="02020603050405020304" pitchFamily="18" charset="0"/>
               </a:rPr>
-              <a:t>Design Flow</a:t>
-            </a:r>
-            <a:endParaRPr lang="en-US" sz="2400" dirty="0">
-              <a:solidFill>
-                <a:schemeClr val="bg1">
-                  <a:lumMod val="65000"/>
-                </a:schemeClr>
-              </a:solidFill>
-              <a:latin typeface="Times New Roman" panose="02020603050405020304" pitchFamily="18" charset="0"/>
-              <a:cs typeface="Times New Roman" panose="02020603050405020304" pitchFamily="18" charset="0"/>
-            </a:endParaRPr>
+              <a:t>JTAG Debug Flow</a:t>
+            </a:r>
           </a:p>
           <a:p>
             <a:pPr marL="285750" indent="-285750">
@@ -16606,6 +16583,625 @@
     <p:extLst>
       <p:ext uri="{BB962C8B-B14F-4D97-AF65-F5344CB8AC3E}">
         <p14:creationId xmlns:p14="http://schemas.microsoft.com/office/powerpoint/2010/main" val="3443148977"/>
+      </p:ext>
+    </p:extLst>
+  </p:cSld>
+  <p:clrMapOvr>
+    <a:masterClrMapping/>
+  </p:clrMapOvr>
+</p:sld>
+</file>
+
+<file path=ppt/slides/slide30.xml><?xml version="1.0" encoding="utf-8"?>
+<p:sld xmlns:a="http://schemas.openxmlformats.org/drawingml/2006/main" xmlns:r="http://schemas.openxmlformats.org/officeDocument/2006/relationships" xmlns:p="http://schemas.openxmlformats.org/presentationml/2006/main">
+  <p:cSld>
+    <p:spTree>
+      <p:nvGrpSpPr>
+        <p:cNvPr id="1" name=""/>
+        <p:cNvGrpSpPr/>
+        <p:nvPr/>
+      </p:nvGrpSpPr>
+      <p:grpSpPr>
+        <a:xfrm>
+          <a:off x="0" y="0"/>
+          <a:ext cx="0" cy="0"/>
+          <a:chOff x="0" y="0"/>
+          <a:chExt cx="0" cy="0"/>
+        </a:xfrm>
+      </p:grpSpPr>
+      <p:sp>
+        <p:nvSpPr>
+          <p:cNvPr id="129" name="PlaceHolder 1"/>
+          <p:cNvSpPr>
+            <a:spLocks noGrp="1"/>
+          </p:cNvSpPr>
+          <p:nvPr>
+            <p:ph type="title"/>
+          </p:nvPr>
+        </p:nvSpPr>
+        <p:spPr>
+          <a:xfrm>
+            <a:off x="1015920" y="0"/>
+            <a:ext cx="10972080" cy="1142280"/>
+          </a:xfrm>
+          <a:prstGeom prst="rect">
+            <a:avLst/>
+          </a:prstGeom>
+          <a:noFill/>
+          <a:ln w="0">
+            <a:noFill/>
+          </a:ln>
+        </p:spPr>
+        <p:txBody>
+          <a:bodyPr lIns="91440" tIns="45720" rIns="91440" bIns="45720" anchor="ctr">
+            <a:noAutofit/>
+          </a:bodyPr>
+          <a:lstStyle/>
+          <a:p>
+            <a:pPr indent="0">
+              <a:lnSpc>
+                <a:spcPct val="100000"/>
+              </a:lnSpc>
+              <a:buNone/>
+              <a:tabLst>
+                <a:tab pos="0" algn="l"/>
+              </a:tabLst>
+            </a:pPr>
+            <a:r>
+              <a:rPr lang="en-US" sz="4000" b="1" spc="-1" dirty="0">
+                <a:solidFill>
+                  <a:srgbClr val="DDDDDD"/>
+                </a:solidFill>
+                <a:latin typeface="Calibri"/>
+                <a:ea typeface="Calibri"/>
+              </a:rPr>
+              <a:t>Standalone Boot Sequence</a:t>
+            </a:r>
+            <a:endParaRPr lang="en-US" sz="4000" b="0" strike="noStrike" spc="-1" dirty="0">
+              <a:solidFill>
+                <a:srgbClr val="000000"/>
+              </a:solidFill>
+              <a:latin typeface="Arial"/>
+            </a:endParaRPr>
+          </a:p>
+        </p:txBody>
+      </p:sp>
+      <p:sp>
+        <p:nvSpPr>
+          <p:cNvPr id="131" name="AutoShape 3"/>
+          <p:cNvSpPr/>
+          <p:nvPr/>
+        </p:nvSpPr>
+        <p:spPr>
+          <a:xfrm>
+            <a:off x="5943600" y="3276720"/>
+            <a:ext cx="304200" cy="304200"/>
+          </a:xfrm>
+          <a:prstGeom prst="rect">
+            <a:avLst/>
+          </a:prstGeom>
+          <a:noFill/>
+          <a:ln w="0">
+            <a:noFill/>
+          </a:ln>
+        </p:spPr>
+        <p:style>
+          <a:lnRef idx="0">
+            <a:scrgbClr r="0" g="0" b="0"/>
+          </a:lnRef>
+          <a:fillRef idx="0">
+            <a:scrgbClr r="0" g="0" b="0"/>
+          </a:fillRef>
+          <a:effectRef idx="0">
+            <a:scrgbClr r="0" g="0" b="0"/>
+          </a:effectRef>
+          <a:fontRef idx="minor"/>
+        </p:style>
+        <p:txBody>
+          <a:bodyPr lIns="90000" tIns="45000" rIns="90000" bIns="45000" numCol="1" spcCol="0" anchor="t">
+            <a:noAutofit/>
+          </a:bodyPr>
+          <a:lstStyle/>
+          <a:p>
+            <a:pPr>
+              <a:lnSpc>
+                <a:spcPct val="100000"/>
+              </a:lnSpc>
+            </a:pPr>
+            <a:endParaRPr lang="en-US" sz="1400" b="0" strike="noStrike" spc="-1">
+              <a:solidFill>
+                <a:srgbClr val="000000"/>
+              </a:solidFill>
+              <a:latin typeface="Arial"/>
+              <a:ea typeface="Arial"/>
+            </a:endParaRPr>
+          </a:p>
+        </p:txBody>
+      </p:sp>
+      <p:sp>
+        <p:nvSpPr>
+          <p:cNvPr id="2" name="動作按鈕: 說明 1">
+            <a:hlinkClick r:id="" action="ppaction://noaction" highlightClick="1"/>
+            <a:extLst>
+              <a:ext uri="{FF2B5EF4-FFF2-40B4-BE49-F238E27FC236}">
+                <a16:creationId xmlns:a16="http://schemas.microsoft.com/office/drawing/2014/main" id="{003DCC72-29F7-D867-D27E-E276AEB886E7}"/>
+              </a:ext>
+            </a:extLst>
+          </p:cNvPr>
+          <p:cNvSpPr/>
+          <p:nvPr/>
+        </p:nvSpPr>
+        <p:spPr>
+          <a:xfrm>
+            <a:off x="2554664" y="2309567"/>
+            <a:ext cx="6985262" cy="3167406"/>
+          </a:xfrm>
+          <a:prstGeom prst="actionButtonHelp">
+            <a:avLst/>
+          </a:prstGeom>
+        </p:spPr>
+        <p:style>
+          <a:lnRef idx="2">
+            <a:schemeClr val="accent1">
+              <a:shade val="15000"/>
+            </a:schemeClr>
+          </a:lnRef>
+          <a:fillRef idx="1">
+            <a:schemeClr val="accent1"/>
+          </a:fillRef>
+          <a:effectRef idx="0">
+            <a:schemeClr val="accent1"/>
+          </a:effectRef>
+          <a:fontRef idx="minor">
+            <a:schemeClr val="lt1"/>
+          </a:fontRef>
+        </p:style>
+        <p:txBody>
+          <a:bodyPr rtlCol="0" anchor="ctr"/>
+          <a:lstStyle/>
+          <a:p>
+            <a:pPr algn="ctr"/>
+            <a:endParaRPr lang="en-US"/>
+          </a:p>
+        </p:txBody>
+      </p:sp>
+      <p:sp>
+        <p:nvSpPr>
+          <p:cNvPr id="3" name="Slide Number Placeholder 2">
+            <a:extLst>
+              <a:ext uri="{FF2B5EF4-FFF2-40B4-BE49-F238E27FC236}">
+                <a16:creationId xmlns:a16="http://schemas.microsoft.com/office/drawing/2014/main" id="{0228BB30-CB0B-8427-25AF-A0CA255B402F}"/>
+              </a:ext>
+            </a:extLst>
+          </p:cNvPr>
+          <p:cNvSpPr>
+            <a:spLocks noGrp="1"/>
+          </p:cNvSpPr>
+          <p:nvPr>
+            <p:ph type="sldNum" idx="10"/>
+          </p:nvPr>
+        </p:nvSpPr>
+        <p:spPr/>
+        <p:txBody>
+          <a:bodyPr/>
+          <a:lstStyle/>
+          <a:p>
+            <a:fld id="{5E7A655E-BA10-45EB-B439-1EA08694B58E}" type="slidenum">
+              <a:rPr lang="en-TW" smtClean="0"/>
+              <a:t>30</a:t>
+            </a:fld>
+            <a:endParaRPr lang="en-TW"/>
+          </a:p>
+        </p:txBody>
+      </p:sp>
+    </p:spTree>
+  </p:cSld>
+  <p:clrMapOvr>
+    <a:masterClrMapping/>
+  </p:clrMapOvr>
+</p:sld>
+</file>
+
+<file path=ppt/slides/slide31.xml><?xml version="1.0" encoding="utf-8"?>
+<p:sld xmlns:a="http://schemas.openxmlformats.org/drawingml/2006/main" xmlns:r="http://schemas.openxmlformats.org/officeDocument/2006/relationships" xmlns:p="http://schemas.openxmlformats.org/presentationml/2006/main">
+  <p:cSld>
+    <p:spTree>
+      <p:nvGrpSpPr>
+        <p:cNvPr id="1" name="">
+          <a:extLst>
+            <a:ext uri="{FF2B5EF4-FFF2-40B4-BE49-F238E27FC236}">
+              <a16:creationId xmlns:a16="http://schemas.microsoft.com/office/drawing/2014/main" id="{EF09146F-4393-892E-2F12-74F505DADA0A}"/>
+            </a:ext>
+          </a:extLst>
+        </p:cNvPr>
+        <p:cNvGrpSpPr/>
+        <p:nvPr/>
+      </p:nvGrpSpPr>
+      <p:grpSpPr>
+        <a:xfrm>
+          <a:off x="0" y="0"/>
+          <a:ext cx="0" cy="0"/>
+          <a:chOff x="0" y="0"/>
+          <a:chExt cx="0" cy="0"/>
+        </a:xfrm>
+      </p:grpSpPr>
+      <p:sp>
+        <p:nvSpPr>
+          <p:cNvPr id="129" name="PlaceHolder 1">
+            <a:extLst>
+              <a:ext uri="{FF2B5EF4-FFF2-40B4-BE49-F238E27FC236}">
+                <a16:creationId xmlns:a16="http://schemas.microsoft.com/office/drawing/2014/main" id="{733187EC-F55F-314C-501F-ABB344AAF66F}"/>
+              </a:ext>
+            </a:extLst>
+          </p:cNvPr>
+          <p:cNvSpPr>
+            <a:spLocks noGrp="1"/>
+          </p:cNvSpPr>
+          <p:nvPr>
+            <p:ph type="title"/>
+          </p:nvPr>
+        </p:nvSpPr>
+        <p:spPr>
+          <a:xfrm>
+            <a:off x="1015920" y="0"/>
+            <a:ext cx="10972080" cy="1142280"/>
+          </a:xfrm>
+          <a:prstGeom prst="rect">
+            <a:avLst/>
+          </a:prstGeom>
+          <a:noFill/>
+          <a:ln w="0">
+            <a:noFill/>
+          </a:ln>
+        </p:spPr>
+        <p:txBody>
+          <a:bodyPr lIns="91440" tIns="45720" rIns="91440" bIns="45720" anchor="ctr">
+            <a:noAutofit/>
+          </a:bodyPr>
+          <a:lstStyle/>
+          <a:p>
+            <a:pPr indent="0">
+              <a:lnSpc>
+                <a:spcPct val="100000"/>
+              </a:lnSpc>
+              <a:buNone/>
+              <a:tabLst>
+                <a:tab pos="0" algn="l"/>
+              </a:tabLst>
+            </a:pPr>
+            <a:r>
+              <a:rPr lang="en-US" altLang="zh-TW" sz="4000" b="1" strike="noStrike" spc="-1" dirty="0">
+                <a:solidFill>
+                  <a:srgbClr val="DDDDDD"/>
+                </a:solidFill>
+                <a:latin typeface="Calibri"/>
+                <a:ea typeface="Calibri"/>
+              </a:rPr>
+              <a:t>Issue to Address</a:t>
+            </a:r>
+            <a:endParaRPr lang="en-US" sz="4000" b="0" strike="noStrike" spc="-1" dirty="0">
+              <a:solidFill>
+                <a:srgbClr val="000000"/>
+              </a:solidFill>
+              <a:latin typeface="Arial"/>
+            </a:endParaRPr>
+          </a:p>
+        </p:txBody>
+      </p:sp>
+      <p:sp>
+        <p:nvSpPr>
+          <p:cNvPr id="131" name="AutoShape 3">
+            <a:extLst>
+              <a:ext uri="{FF2B5EF4-FFF2-40B4-BE49-F238E27FC236}">
+                <a16:creationId xmlns:a16="http://schemas.microsoft.com/office/drawing/2014/main" id="{2CC01002-543C-89A6-5077-F58D57F7F171}"/>
+              </a:ext>
+            </a:extLst>
+          </p:cNvPr>
+          <p:cNvSpPr/>
+          <p:nvPr/>
+        </p:nvSpPr>
+        <p:spPr>
+          <a:xfrm>
+            <a:off x="5943600" y="3276720"/>
+            <a:ext cx="304200" cy="304200"/>
+          </a:xfrm>
+          <a:prstGeom prst="rect">
+            <a:avLst/>
+          </a:prstGeom>
+          <a:noFill/>
+          <a:ln w="0">
+            <a:noFill/>
+          </a:ln>
+        </p:spPr>
+        <p:style>
+          <a:lnRef idx="0">
+            <a:scrgbClr r="0" g="0" b="0"/>
+          </a:lnRef>
+          <a:fillRef idx="0">
+            <a:scrgbClr r="0" g="0" b="0"/>
+          </a:fillRef>
+          <a:effectRef idx="0">
+            <a:scrgbClr r="0" g="0" b="0"/>
+          </a:effectRef>
+          <a:fontRef idx="minor"/>
+        </p:style>
+        <p:txBody>
+          <a:bodyPr lIns="90000" tIns="45000" rIns="90000" bIns="45000" numCol="1" spcCol="0" anchor="t">
+            <a:noAutofit/>
+          </a:bodyPr>
+          <a:lstStyle/>
+          <a:p>
+            <a:pPr>
+              <a:lnSpc>
+                <a:spcPct val="100000"/>
+              </a:lnSpc>
+            </a:pPr>
+            <a:endParaRPr lang="en-US" sz="1400" b="0" strike="noStrike" spc="-1">
+              <a:solidFill>
+                <a:srgbClr val="000000"/>
+              </a:solidFill>
+              <a:latin typeface="Arial"/>
+              <a:ea typeface="Arial"/>
+            </a:endParaRPr>
+          </a:p>
+        </p:txBody>
+      </p:sp>
+      <p:sp>
+        <p:nvSpPr>
+          <p:cNvPr id="2" name="文字方塊 1">
+            <a:extLst>
+              <a:ext uri="{FF2B5EF4-FFF2-40B4-BE49-F238E27FC236}">
+                <a16:creationId xmlns:a16="http://schemas.microsoft.com/office/drawing/2014/main" id="{00ADD298-6CC4-87F8-4C0B-13D75EAD4D37}"/>
+              </a:ext>
+            </a:extLst>
+          </p:cNvPr>
+          <p:cNvSpPr txBox="1"/>
+          <p:nvPr/>
+        </p:nvSpPr>
+        <p:spPr>
+          <a:xfrm>
+            <a:off x="598394" y="1707776"/>
+            <a:ext cx="10972080" cy="3046988"/>
+          </a:xfrm>
+          <a:prstGeom prst="rect">
+            <a:avLst/>
+          </a:prstGeom>
+          <a:noFill/>
+        </p:spPr>
+        <p:txBody>
+          <a:bodyPr wrap="square" rtlCol="0">
+            <a:spAutoFit/>
+          </a:bodyPr>
+          <a:lstStyle/>
+          <a:p>
+            <a:pPr marL="285750" indent="-285750">
+              <a:buFont typeface="Arial" panose="020B0604020202020204" pitchFamily="34" charset="0"/>
+              <a:buChar char="•"/>
+            </a:pPr>
+            <a:r>
+              <a:rPr lang="en-US" sz="2400" dirty="0">
+                <a:latin typeface="Times New Roman" panose="02020603050405020304" pitchFamily="18" charset="0"/>
+                <a:cs typeface="Times New Roman" panose="02020603050405020304" pitchFamily="18" charset="0"/>
+              </a:rPr>
+              <a:t>Interrupt (GPIO / Timer)</a:t>
+            </a:r>
+          </a:p>
+          <a:p>
+            <a:pPr marL="285750" indent="-285750">
+              <a:buFont typeface="Arial" panose="020B0604020202020204" pitchFamily="34" charset="0"/>
+              <a:buChar char="•"/>
+            </a:pPr>
+            <a:r>
+              <a:rPr lang="en-US" sz="2400" dirty="0">
+                <a:latin typeface="Times New Roman" panose="02020603050405020304" pitchFamily="18" charset="0"/>
+                <a:cs typeface="Times New Roman" panose="02020603050405020304" pitchFamily="18" charset="0"/>
+              </a:rPr>
+              <a:t>GPIO input </a:t>
+            </a:r>
+          </a:p>
+          <a:p>
+            <a:pPr marL="285750" indent="-285750">
+              <a:buFont typeface="Arial" panose="020B0604020202020204" pitchFamily="34" charset="0"/>
+              <a:buChar char="•"/>
+            </a:pPr>
+            <a:r>
+              <a:rPr lang="en-US" sz="2400" dirty="0" err="1">
+                <a:latin typeface="Times New Roman" panose="02020603050405020304" pitchFamily="18" charset="0"/>
+                <a:cs typeface="Times New Roman" panose="02020603050405020304" pitchFamily="18" charset="0"/>
+              </a:rPr>
+              <a:t>uart</a:t>
+            </a:r>
+            <a:r>
+              <a:rPr lang="en-US" sz="2400" dirty="0">
+                <a:latin typeface="Times New Roman" panose="02020603050405020304" pitchFamily="18" charset="0"/>
+                <a:cs typeface="Times New Roman" panose="02020603050405020304" pitchFamily="18" charset="0"/>
+              </a:rPr>
+              <a:t> 16550 Baud Rate </a:t>
+            </a:r>
+            <a:r>
+              <a:rPr lang="zh-TW" altLang="en-US" sz="2400" dirty="0">
+                <a:latin typeface="Times New Roman" panose="02020603050405020304" pitchFamily="18" charset="0"/>
+                <a:cs typeface="Times New Roman" panose="02020603050405020304" pitchFamily="18" charset="0"/>
+              </a:rPr>
+              <a:t>更改 </a:t>
+            </a:r>
+            <a:endParaRPr lang="en-US" altLang="zh-TW" sz="2400" dirty="0">
+              <a:latin typeface="Times New Roman" panose="02020603050405020304" pitchFamily="18" charset="0"/>
+              <a:cs typeface="Times New Roman" panose="02020603050405020304" pitchFamily="18" charset="0"/>
+            </a:endParaRPr>
+          </a:p>
+          <a:p>
+            <a:pPr marL="285750" indent="-285750">
+              <a:buFont typeface="Arial" panose="020B0604020202020204" pitchFamily="34" charset="0"/>
+              <a:buChar char="•"/>
+            </a:pPr>
+            <a:r>
+              <a:rPr lang="en-US" sz="2400" dirty="0">
+                <a:latin typeface="Times New Roman" panose="02020603050405020304" pitchFamily="18" charset="0"/>
+                <a:cs typeface="Times New Roman" panose="02020603050405020304" pitchFamily="18" charset="0"/>
+              </a:rPr>
+              <a:t>XADC </a:t>
+            </a:r>
+            <a:r>
+              <a:rPr lang="zh-TW" altLang="en-US" sz="2400" dirty="0">
+                <a:latin typeface="Times New Roman" panose="02020603050405020304" pitchFamily="18" charset="0"/>
+                <a:cs typeface="Times New Roman" panose="02020603050405020304" pitchFamily="18" charset="0"/>
+              </a:rPr>
+              <a:t>五個</a:t>
+            </a:r>
+            <a:r>
+              <a:rPr lang="en-US" altLang="zh-TW" sz="2400" dirty="0">
+                <a:latin typeface="Times New Roman" panose="02020603050405020304" pitchFamily="18" charset="0"/>
+                <a:cs typeface="Times New Roman" panose="02020603050405020304" pitchFamily="18" charset="0"/>
+              </a:rPr>
+              <a:t>channel</a:t>
+            </a:r>
+            <a:r>
+              <a:rPr lang="zh-TW" altLang="en-US" sz="2400" dirty="0">
+                <a:latin typeface="Times New Roman" panose="02020603050405020304" pitchFamily="18" charset="0"/>
+                <a:cs typeface="Times New Roman" panose="02020603050405020304" pitchFamily="18" charset="0"/>
+              </a:rPr>
+              <a:t>讀值</a:t>
+            </a:r>
+            <a:endParaRPr lang="en-US" sz="2400" dirty="0">
+              <a:latin typeface="Times New Roman" panose="02020603050405020304" pitchFamily="18" charset="0"/>
+              <a:cs typeface="Times New Roman" panose="02020603050405020304" pitchFamily="18" charset="0"/>
+            </a:endParaRPr>
+          </a:p>
+          <a:p>
+            <a:pPr marL="285750" indent="-285750">
+              <a:buFont typeface="Arial" panose="020B0604020202020204" pitchFamily="34" charset="0"/>
+              <a:buChar char="•"/>
+            </a:pPr>
+            <a:r>
+              <a:rPr lang="en-US" sz="2400" dirty="0">
+                <a:latin typeface="Times New Roman" panose="02020603050405020304" pitchFamily="18" charset="0"/>
+                <a:cs typeface="Times New Roman" panose="02020603050405020304" pitchFamily="18" charset="0"/>
+              </a:rPr>
+              <a:t>QSPI </a:t>
+            </a:r>
+            <a:r>
+              <a:rPr lang="zh-TW" altLang="en-US" sz="2400" dirty="0">
+                <a:latin typeface="Times New Roman" panose="02020603050405020304" pitchFamily="18" charset="0"/>
+                <a:cs typeface="Times New Roman" panose="02020603050405020304" pitchFamily="18" charset="0"/>
+              </a:rPr>
+              <a:t>內建 </a:t>
+            </a:r>
+            <a:r>
+              <a:rPr lang="en-US" sz="2400" dirty="0">
+                <a:latin typeface="Times New Roman" panose="02020603050405020304" pitchFamily="18" charset="0"/>
+                <a:cs typeface="Times New Roman" panose="02020603050405020304" pitchFamily="18" charset="0"/>
+              </a:rPr>
+              <a:t>Bitstream </a:t>
+            </a:r>
+          </a:p>
+          <a:p>
+            <a:pPr marL="285750" indent="-285750">
+              <a:buFont typeface="Arial" panose="020B0604020202020204" pitchFamily="34" charset="0"/>
+              <a:buChar char="•"/>
+            </a:pPr>
+            <a:r>
+              <a:rPr lang="en-US" sz="2400" dirty="0">
+                <a:latin typeface="Times New Roman" panose="02020603050405020304" pitchFamily="18" charset="0"/>
+                <a:cs typeface="Times New Roman" panose="02020603050405020304" pitchFamily="18" charset="0"/>
+              </a:rPr>
+              <a:t>EMC SRAM </a:t>
+            </a:r>
+            <a:r>
+              <a:rPr lang="zh-TW" altLang="en-US" sz="2400" dirty="0">
+                <a:latin typeface="Times New Roman" panose="02020603050405020304" pitchFamily="18" charset="0"/>
+                <a:cs typeface="Times New Roman" panose="02020603050405020304" pitchFamily="18" charset="0"/>
+              </a:rPr>
+              <a:t>使用</a:t>
+            </a:r>
+            <a:endParaRPr lang="en-US" altLang="zh-TW" sz="2400" dirty="0">
+              <a:latin typeface="Times New Roman" panose="02020603050405020304" pitchFamily="18" charset="0"/>
+              <a:cs typeface="Times New Roman" panose="02020603050405020304" pitchFamily="18" charset="0"/>
+            </a:endParaRPr>
+          </a:p>
+          <a:p>
+            <a:pPr marL="285750" indent="-285750">
+              <a:buFont typeface="Arial" panose="020B0604020202020204" pitchFamily="34" charset="0"/>
+              <a:buChar char="•"/>
+            </a:pPr>
+            <a:r>
+              <a:rPr lang="en-US" sz="2400" dirty="0">
+                <a:latin typeface="Times New Roman" panose="02020603050405020304" pitchFamily="18" charset="0"/>
+                <a:cs typeface="Times New Roman" panose="02020603050405020304" pitchFamily="18" charset="0"/>
+              </a:rPr>
+              <a:t>Memory Hier</a:t>
+            </a:r>
+            <a:r>
+              <a:rPr lang="zh-TW" altLang="en-US" sz="2400" dirty="0">
+                <a:latin typeface="Times New Roman" panose="02020603050405020304" pitchFamily="18" charset="0"/>
+                <a:cs typeface="Times New Roman" panose="02020603050405020304" pitchFamily="18" charset="0"/>
+              </a:rPr>
+              <a:t> 設計</a:t>
+            </a:r>
+            <a:endParaRPr lang="en-US" altLang="zh-TW" sz="2400" dirty="0">
+              <a:latin typeface="Times New Roman" panose="02020603050405020304" pitchFamily="18" charset="0"/>
+              <a:cs typeface="Times New Roman" panose="02020603050405020304" pitchFamily="18" charset="0"/>
+            </a:endParaRPr>
+          </a:p>
+          <a:p>
+            <a:pPr marL="285750" indent="-285750">
+              <a:buFont typeface="Arial" panose="020B0604020202020204" pitchFamily="34" charset="0"/>
+              <a:buChar char="•"/>
+            </a:pPr>
+            <a:r>
+              <a:rPr lang="en-US" altLang="zh-TW" sz="2400" dirty="0">
+                <a:latin typeface="Times New Roman" panose="02020603050405020304" pitchFamily="18" charset="0"/>
+                <a:cs typeface="Times New Roman" panose="02020603050405020304" pitchFamily="18" charset="0"/>
+              </a:rPr>
+              <a:t>Standalone Boot Sequence</a:t>
+            </a:r>
+            <a:r>
+              <a:rPr lang="zh-TW" altLang="en-US" sz="2400" dirty="0">
+                <a:latin typeface="Times New Roman" panose="02020603050405020304" pitchFamily="18" charset="0"/>
+                <a:cs typeface="Times New Roman" panose="02020603050405020304" pitchFamily="18" charset="0"/>
+              </a:rPr>
+              <a:t>流程</a:t>
+            </a:r>
+            <a:endParaRPr lang="en-US" sz="2400" dirty="0">
+              <a:latin typeface="Times New Roman" panose="02020603050405020304" pitchFamily="18" charset="0"/>
+              <a:cs typeface="Times New Roman" panose="02020603050405020304" pitchFamily="18" charset="0"/>
+            </a:endParaRPr>
+          </a:p>
+        </p:txBody>
+      </p:sp>
+      <p:sp>
+        <p:nvSpPr>
+          <p:cNvPr id="3" name="Slide Number Placeholder 2">
+            <a:extLst>
+              <a:ext uri="{FF2B5EF4-FFF2-40B4-BE49-F238E27FC236}">
+                <a16:creationId xmlns:a16="http://schemas.microsoft.com/office/drawing/2014/main" id="{8EC85FAF-B12B-E4FB-0C54-D03C84646C5C}"/>
+              </a:ext>
+            </a:extLst>
+          </p:cNvPr>
+          <p:cNvSpPr>
+            <a:spLocks noGrp="1"/>
+          </p:cNvSpPr>
+          <p:nvPr>
+            <p:ph type="sldNum" idx="10"/>
+          </p:nvPr>
+        </p:nvSpPr>
+        <p:spPr/>
+        <p:txBody>
+          <a:bodyPr/>
+          <a:lstStyle/>
+          <a:p>
+            <a:fld id="{5E7A655E-BA10-45EB-B439-1EA08694B58E}" type="slidenum">
+              <a:rPr lang="en-TW" smtClean="0"/>
+              <a:t>31</a:t>
+            </a:fld>
+            <a:endParaRPr lang="en-TW"/>
+          </a:p>
+        </p:txBody>
+      </p:sp>
+    </p:spTree>
+    <p:extLst>
+      <p:ext uri="{BB962C8B-B14F-4D97-AF65-F5344CB8AC3E}">
+        <p14:creationId xmlns:p14="http://schemas.microsoft.com/office/powerpoint/2010/main" val="1021360517"/>
       </p:ext>
     </p:extLst>
   </p:cSld>
@@ -19445,7 +20041,7 @@
         <p:spPr>
           <a:xfrm>
             <a:off x="572575" y="1468582"/>
-            <a:ext cx="11213772" cy="3903954"/>
+            <a:ext cx="11213772" cy="4457952"/>
           </a:xfrm>
           <a:prstGeom prst="rect">
             <a:avLst/>
@@ -19609,6 +20205,27 @@
                 <a:cs typeface="Times New Roman" panose="02020603050405020304" pitchFamily="18" charset="0"/>
               </a:rPr>
               <a:t>Software Design Flow</a:t>
+            </a:r>
+          </a:p>
+          <a:p>
+            <a:pPr marL="285750" indent="-285750">
+              <a:lnSpc>
+                <a:spcPct val="150000"/>
+              </a:lnSpc>
+              <a:buFont typeface="Arial" panose="020B0604020202020204" pitchFamily="34" charset="0"/>
+              <a:buChar char="•"/>
+            </a:pPr>
+            <a:r>
+              <a:rPr lang="en-US" sz="2400" dirty="0">
+                <a:solidFill>
+                  <a:schemeClr val="bg1">
+                    <a:lumMod val="65000"/>
+                  </a:schemeClr>
+                </a:solidFill>
+                <a:latin typeface="Times New Roman" panose="02020603050405020304" pitchFamily="18" charset="0"/>
+                <a:cs typeface="Times New Roman" panose="02020603050405020304" pitchFamily="18" charset="0"/>
+              </a:rPr>
+              <a:t>JTAG Debug Flow</a:t>
             </a:r>
           </a:p>
           <a:p>

</xml_diff>

<commit_message>
Update README to enhance processor details for clarity
</commit_message>
<xml_diff>
--- a/Intro_PPT/RISCV-MCU.pptx
+++ b/Intro_PPT/RISCV-MCU.pptx
@@ -6696,7 +6696,15 @@
             </a:r>
             <a:r>
               <a:rPr lang="en-US" sz="2400" dirty="0"/>
-              <a:t>, Single Core</a:t>
+              <a:t>, Single Core, </a:t>
+            </a:r>
+            <a:r>
+              <a:rPr lang="en-US" sz="2400" dirty="0">
+                <a:solidFill>
+                  <a:srgbClr val="FF0000"/>
+                </a:solidFill>
+              </a:rPr>
+              <a:t>5-Stage Pipeline</a:t>
             </a:r>
           </a:p>
           <a:p>

</xml_diff>